<commit_message>
S5 — Wireframes refaits en maquettes desktop couleur (12 ecrans 1440x900, portail client desktop, palette bleu sante) ; README, matrice de tracabilite ENF-04 et page ecrans du deck mis a jour
</commit_message>
<xml_diff>
--- a/06-Restitution/deck-executive-banque-elyssa.pptx
+++ b/06-Restitution/deck-executive-banque-elyssa.pptx
@@ -4218,7 +4218,7 @@
                 <a:latin typeface="Segoe UI"/>
                 <a:ea typeface="Segoe UI"/>
               </a:rPr>
-              <a:t>LES ÉCRANS — MAQUETTES LOW-FI</a:t>
+              <a:t>LES ÉCRANS — MAQUETTES MID-FI COULEUR</a:t>
             </a:r>
           </a:p>
         </p:txBody>
@@ -4366,17 +4366,6 @@
               </a:lnSpc>
             </a:pPr>
             <a:r>
-              <a:rPr sz="1200" b="1">
-                <a:solidFill>
-                  <a:srgbClr val="2E7D8C"/>
-                </a:solidFill>
-                <a:latin typeface="Segoe UI"/>
-                <a:ea typeface="Segoe UI"/>
-              </a:rPr>
-              <a:t>Mobile 390 × 844 · Desktop 1440 × 900</a:t>
-            </a:r>
-            <a:br/>
-            <a:r>
               <a:rPr sz="1200">
                 <a:solidFill>
                   <a:srgbClr val="243B45"/>
@@ -4384,17 +4373,68 @@
                 <a:latin typeface="Segoe UI"/>
                 <a:ea typeface="Segoe UI"/>
               </a:rPr>
-              <a:t>Niveaux de gris, cibles tactiles ≥ 44 px. Chaque frame référence ses user stories (US) et ses règles de gestion (RG).</a:t>
+              <a:t>Desktop 1440 × 900 — client et siège,</a:t>
+            </a:r>
+          </a:p>
+          <a:p>
+            <a:pPr algn="l">
+              <a:lnSpc>
+                <a:spcPct val="135000"/>
+              </a:lnSpc>
+            </a:pPr>
+            <a:r>
+              <a:rPr sz="1200">
+                <a:solidFill>
+                  <a:srgbClr val="243B45"/>
+                </a:solidFill>
+                <a:latin typeface="Segoe UI"/>
+                <a:ea typeface="Segoe UI"/>
+              </a:rPr>
+              <a:t>mid-fidelity couleur, cibles ≥ 44 px.</a:t>
+            </a:r>
+          </a:p>
+          <a:p>
+            <a:pPr algn="l">
+              <a:lnSpc>
+                <a:spcPct val="135000"/>
+              </a:lnSpc>
+            </a:pPr>
+            <a:r>
+              <a:rPr sz="1200">
+                <a:solidFill>
+                  <a:srgbClr val="243B45"/>
+                </a:solidFill>
+                <a:latin typeface="Segoe UI"/>
+                <a:ea typeface="Segoe UI"/>
+              </a:rPr>
+              <a:t>Chaque frame référence ses user stories (US)</a:t>
+            </a:r>
+          </a:p>
+          <a:p>
+            <a:pPr algn="l">
+              <a:lnSpc>
+                <a:spcPct val="135000"/>
+              </a:lnSpc>
+            </a:pPr>
+            <a:r>
+              <a:rPr sz="1200">
+                <a:solidFill>
+                  <a:srgbClr val="243B45"/>
+                </a:solidFill>
+                <a:latin typeface="Segoe UI"/>
+                <a:ea typeface="Segoe UI"/>
+              </a:rPr>
+              <a:t>et ses règles de gestion (RG).</a:t>
             </a:r>
           </a:p>
         </p:txBody>
       </p:sp>
       <p:pic>
         <p:nvPicPr>
-          <p:cNvPr id="8" name="Picture 8">
-            <a:extLst>
-              <a:ext uri="{FF2B5EF4-FFF2-40B4-BE49-F238E27FC236}">
-                <a16:creationId xmlns:a16="http://schemas.microsoft.com/office/drawing/2014/main" id="{0CBE2715-D552-4955-A49F-EBE042CA3633}"/>
+          <p:cNvPr id="9" name="Picture 9">
+            <a:extLst>
+              <a:ext uri="{FF2B5EF4-FFF2-40B4-BE49-F238E27FC236}">
+                <a16:creationId xmlns:a16="http://schemas.microsoft.com/office/drawing/2014/main" id="{9254C717-2346-483F-AB5E-9394A2A78CFE}"/>
               </a:ext>
             </a:extLst>
           </p:cNvPr>
@@ -4402,51 +4442,22 @@
           <p:nvPr/>
         </p:nvPicPr>
         <p:blipFill>
-          <a:blip r:embed="rId2"/>
-          <a:srcRect l="11014" r="11014"/>
+          <a:blip r:embed="rId6"/>
+          <a:srcRect t="2403" b="2403"/>
           <a:stretch>
             <a:fillRect/>
           </a:stretch>
         </p:blipFill>
         <p:spPr>
           <a:xfrm>
-            <a:off x="4762500" y="1047750"/>
-            <a:ext cx="2019300" cy="4381500"/>
+            <a:off x="8096250" y="1238250"/>
+            <a:ext cx="3333750" cy="2181225"/>
           </a:xfrm>
           <a:prstGeom prst="rect">
             <a:avLst/>
           </a:prstGeom>
         </p:spPr>
       </p:pic>
-      <p:pic>
-        <p:nvPicPr>
-          <p:cNvPr id="9" name="Picture 9">
-            <a:extLst>
-              <a:ext uri="{FF2B5EF4-FFF2-40B4-BE49-F238E27FC236}">
-                <a16:creationId xmlns:a16="http://schemas.microsoft.com/office/drawing/2014/main" id="{9254C717-2346-483F-AB5E-9394A2A78CFE}"/>
-              </a:ext>
-            </a:extLst>
-          </p:cNvPr>
-          <p:cNvPicPr/>
-          <p:nvPr/>
-        </p:nvPicPr>
-        <p:blipFill>
-          <a:blip r:embed="rId3"/>
-          <a:srcRect t="1645" b="1645"/>
-          <a:stretch>
-            <a:fillRect/>
-          </a:stretch>
-        </p:blipFill>
-        <p:spPr>
-          <a:xfrm>
-            <a:off x="7048500" y="1047750"/>
-            <a:ext cx="4381500" cy="2733675"/>
-          </a:xfrm>
-          <a:prstGeom prst="rect">
-            <a:avLst/>
-          </a:prstGeom>
-        </p:spPr>
-      </p:pic>
       <p:sp>
         <p:nvSpPr>
           <p:cNvPr id="10" name="TextBox 10">
@@ -4461,8 +4472,8 @@
         </p:nvSpPr>
         <p:spPr>
           <a:xfrm>
-            <a:off x="7048500" y="3952875"/>
-            <a:ext cx="4381500" cy="1428750"/>
+            <a:off x="4572000" y="3619500"/>
+            <a:ext cx="6858000" cy="1428750"/>
           </a:xfrm>
         </p:spPr>
         <p:txBody>
@@ -4511,18 +4522,47 @@
           <a:p>
             <a:pPr algn="l"/>
             <a:r>
-              <a:rPr sz="1050" i="1">
+              <a:rPr sz="1100" i="1">
                 <a:solidFill>
                   <a:srgbClr val="9AA6AC"/>
                 </a:solidFill>
                 <a:latin typeface="Segoe UI"/>
                 <a:ea typeface="Segoe UI"/>
               </a:rPr>
-              <a:t>Source : wireframes low-fi (galerie GitHub) — E. Kanzari, 20 novembre 2026</a:t>
-            </a:r>
-          </a:p>
-        </p:txBody>
-      </p:sp>
+              <a:t>Source : maquettes desktop couleur (galerie GitHub) — E. Kanzari, 20 novembre 2026</a:t>
+            </a:r>
+          </a:p>
+        </p:txBody>
+      </p:sp>
+      <p:pic>
+        <p:nvPicPr>
+          <p:cNvPr id="12" name="Picture 12">
+            <a:extLst>
+              <a:ext uri="{FF2B5EF4-FFF2-40B4-BE49-F238E27FC236}">
+                <a16:creationId xmlns:a16="http://schemas.microsoft.com/office/drawing/2014/main" id="{91DD18F4-6A71-4D9A-8941-425D7B987979}"/>
+              </a:ext>
+            </a:extLst>
+          </p:cNvPr>
+          <p:cNvPicPr/>
+          <p:nvPr/>
+        </p:nvPicPr>
+        <p:blipFill>
+          <a:blip r:embed="rId5"/>
+          <a:srcRect t="85" b="85"/>
+          <a:stretch>
+            <a:fillRect/>
+          </a:stretch>
+        </p:blipFill>
+        <p:spPr>
+          <a:xfrm>
+            <a:off x="4572000" y="1238250"/>
+            <a:ext cx="3333750" cy="2181225"/>
+          </a:xfrm>
+          <a:prstGeom prst="rect">
+            <a:avLst/>
+          </a:prstGeom>
+        </p:spPr>
+      </p:pic>
     </p:spTree>
   </p:cSld>
   <p:clrMapOvr>

</xml_diff>